<commit_message>
docs(m10): finalize presentation video in demo folder, update YouTube stream, and polish M10 documentation
</commit_message>
<xml_diff>
--- a/demo/TaskBoard_DevOps_Capstone_Presentation.pptx
+++ b/demo/TaskBoard_DevOps_Capstone_Presentation.pptx
@@ -5318,7 +5318,7 @@
       </p:sp>
       <p:pic>
         <p:nvPicPr>
-          <p:cNvPr id="8" name="Picture 7" descr="01-TaskBoard-DashBoard.jpg"/>
+          <p:cNvPr id="8" name="Picture 7" descr="01-TaskBoard-DashBoard-02.jpg"/>
           <p:cNvPicPr>
             <a:picLocks noChangeAspect="1"/>
           </p:cNvPicPr>
@@ -5333,7 +5333,7 @@
         <p:spPr>
           <a:xfrm>
             <a:off x="3977639" y="1325880"/>
-            <a:ext cx="7635240" cy="3771769"/>
+            <a:ext cx="7635240" cy="4098123"/>
           </a:xfrm>
           <a:prstGeom prst="rect">
             <a:avLst/>
@@ -5370,7 +5370,7 @@
               </a:defRPr>
             </a:pPr>
             <a:r>
-              <a:t>Verified live TaskBoard UI running locally on localhost:3000</a:t>
+              <a:t>Verified live TaskBoard Agile Kanban Board running locally on localhost:3000</a:t>
             </a:r>
           </a:p>
         </p:txBody>

</xml_diff>